<commit_message>
complex constraint update. future development addition.
</commit_message>
<xml_diff>
--- a/figures/constraint_examples.pptx
+++ b/figures/constraint_examples.pptx
@@ -262,7 +262,7 @@
           <a:p>
             <a:fld id="{1A30122B-BC72-41F7-938E-33D4221D7AF9}" type="datetimeFigureOut">
               <a:rPr lang="en-US" smtClean="0"/>
-              <a:t>7/1/25</a:t>
+              <a:t>7/14/25</a:t>
             </a:fld>
             <a:endParaRPr lang="en-US"/>
           </a:p>
@@ -460,7 +460,7 @@
           <a:p>
             <a:fld id="{1A30122B-BC72-41F7-938E-33D4221D7AF9}" type="datetimeFigureOut">
               <a:rPr lang="en-US" smtClean="0"/>
-              <a:t>7/1/25</a:t>
+              <a:t>7/14/25</a:t>
             </a:fld>
             <a:endParaRPr lang="en-US"/>
           </a:p>
@@ -668,7 +668,7 @@
           <a:p>
             <a:fld id="{1A30122B-BC72-41F7-938E-33D4221D7AF9}" type="datetimeFigureOut">
               <a:rPr lang="en-US" smtClean="0"/>
-              <a:t>7/1/25</a:t>
+              <a:t>7/14/25</a:t>
             </a:fld>
             <a:endParaRPr lang="en-US"/>
           </a:p>
@@ -866,7 +866,7 @@
           <a:p>
             <a:fld id="{1A30122B-BC72-41F7-938E-33D4221D7AF9}" type="datetimeFigureOut">
               <a:rPr lang="en-US" smtClean="0"/>
-              <a:t>7/1/25</a:t>
+              <a:t>7/14/25</a:t>
             </a:fld>
             <a:endParaRPr lang="en-US"/>
           </a:p>
@@ -1141,7 +1141,7 @@
           <a:p>
             <a:fld id="{1A30122B-BC72-41F7-938E-33D4221D7AF9}" type="datetimeFigureOut">
               <a:rPr lang="en-US" smtClean="0"/>
-              <a:t>7/1/25</a:t>
+              <a:t>7/14/25</a:t>
             </a:fld>
             <a:endParaRPr lang="en-US"/>
           </a:p>
@@ -1406,7 +1406,7 @@
           <a:p>
             <a:fld id="{1A30122B-BC72-41F7-938E-33D4221D7AF9}" type="datetimeFigureOut">
               <a:rPr lang="en-US" smtClean="0"/>
-              <a:t>7/1/25</a:t>
+              <a:t>7/14/25</a:t>
             </a:fld>
             <a:endParaRPr lang="en-US"/>
           </a:p>
@@ -1818,7 +1818,7 @@
           <a:p>
             <a:fld id="{1A30122B-BC72-41F7-938E-33D4221D7AF9}" type="datetimeFigureOut">
               <a:rPr lang="en-US" smtClean="0"/>
-              <a:t>7/1/25</a:t>
+              <a:t>7/14/25</a:t>
             </a:fld>
             <a:endParaRPr lang="en-US"/>
           </a:p>
@@ -1959,7 +1959,7 @@
           <a:p>
             <a:fld id="{1A30122B-BC72-41F7-938E-33D4221D7AF9}" type="datetimeFigureOut">
               <a:rPr lang="en-US" smtClean="0"/>
-              <a:t>7/1/25</a:t>
+              <a:t>7/14/25</a:t>
             </a:fld>
             <a:endParaRPr lang="en-US"/>
           </a:p>
@@ -2072,7 +2072,7 @@
           <a:p>
             <a:fld id="{1A30122B-BC72-41F7-938E-33D4221D7AF9}" type="datetimeFigureOut">
               <a:rPr lang="en-US" smtClean="0"/>
-              <a:t>7/1/25</a:t>
+              <a:t>7/14/25</a:t>
             </a:fld>
             <a:endParaRPr lang="en-US"/>
           </a:p>
@@ -2383,7 +2383,7 @@
           <a:p>
             <a:fld id="{1A30122B-BC72-41F7-938E-33D4221D7AF9}" type="datetimeFigureOut">
               <a:rPr lang="en-US" smtClean="0"/>
-              <a:t>7/1/25</a:t>
+              <a:t>7/14/25</a:t>
             </a:fld>
             <a:endParaRPr lang="en-US"/>
           </a:p>
@@ -2671,7 +2671,7 @@
           <a:p>
             <a:fld id="{1A30122B-BC72-41F7-938E-33D4221D7AF9}" type="datetimeFigureOut">
               <a:rPr lang="en-US" smtClean="0"/>
-              <a:t>7/1/25</a:t>
+              <a:t>7/14/25</a:t>
             </a:fld>
             <a:endParaRPr lang="en-US"/>
           </a:p>
@@ -2912,7 +2912,7 @@
           <a:p>
             <a:fld id="{1A30122B-BC72-41F7-938E-33D4221D7AF9}" type="datetimeFigureOut">
               <a:rPr lang="en-US" smtClean="0"/>
-              <a:t>7/1/25</a:t>
+              <a:t>7/14/25</a:t>
             </a:fld>
             <a:endParaRPr lang="en-US"/>
           </a:p>
@@ -5416,8 +5416,8 @@
         </p:nvCxnSpPr>
         <p:spPr>
           <a:xfrm rot="16200000" flipH="1">
-            <a:off x="3225338" y="2058645"/>
-            <a:ext cx="598250" cy="677112"/>
+            <a:off x="3306980" y="1977003"/>
+            <a:ext cx="434966" cy="677112"/>
           </a:xfrm>
           <a:prstGeom prst="bentConnector2">
             <a:avLst/>
@@ -5456,7 +5456,7 @@
         <p:spPr>
           <a:xfrm>
             <a:off x="3811355" y="2056105"/>
-            <a:ext cx="2284645" cy="769441"/>
+            <a:ext cx="2284645" cy="600164"/>
           </a:xfrm>
           <a:prstGeom prst="rect">
             <a:avLst/>
@@ -5486,13 +5486,6 @@
             </a:endParaRPr>
           </a:p>
           <a:p>
-            <a:endParaRPr lang="en-US" sz="1100" dirty="0">
-              <a:latin typeface="Cascadia Mono Light" panose="020B0609020000020004" pitchFamily="49" charset="0"/>
-              <a:ea typeface="Cascadia Mono Light" panose="020B0609020000020004" pitchFamily="49" charset="0"/>
-              <a:cs typeface="Cascadia Mono Light" panose="020B0609020000020004" pitchFamily="49" charset="0"/>
-            </a:endParaRPr>
-          </a:p>
-          <a:p>
             <a:r>
               <a:rPr lang="en-US" sz="1100" dirty="0">
                 <a:latin typeface="Cascadia Mono Light" panose="020B0609020000020004" pitchFamily="49" charset="0"/>
@@ -5640,7 +5633,7 @@
         <p:spPr>
           <a:xfrm>
             <a:off x="4414042" y="2061492"/>
-            <a:ext cx="3645230" cy="600164"/>
+            <a:ext cx="3645230" cy="430887"/>
           </a:xfrm>
           <a:prstGeom prst="rect">
             <a:avLst/>
@@ -5669,23 +5662,7 @@
                 <a:ea typeface="Cascadia Mono Light" panose="020B0609020000020004" pitchFamily="49" charset="0"/>
                 <a:cs typeface="Cascadia Mono Light" panose="020B0609020000020004" pitchFamily="49" charset="0"/>
               </a:rPr>
-              <a:t>"Building fronts public open space or 25 percent of </a:t>
-            </a:r>
-            <a:r>
-              <a:rPr lang="en-US" sz="1100" dirty="0" err="1">
-                <a:latin typeface="Cascadia Mono Light" panose="020B0609020000020004" pitchFamily="49" charset="0"/>
-                <a:ea typeface="Cascadia Mono Light" panose="020B0609020000020004" pitchFamily="49" charset="0"/>
-                <a:cs typeface="Cascadia Mono Light" panose="020B0609020000020004" pitchFamily="49" charset="0"/>
-              </a:rPr>
-              <a:t>blockface</a:t>
-            </a:r>
-            <a:r>
-              <a:rPr lang="en-US" sz="1100" dirty="0">
-                <a:latin typeface="Cascadia Mono Light" panose="020B0609020000020004" pitchFamily="49" charset="0"/>
-                <a:ea typeface="Cascadia Mono Light" panose="020B0609020000020004" pitchFamily="49" charset="0"/>
-                <a:cs typeface="Cascadia Mono Light" panose="020B0609020000020004" pitchFamily="49" charset="0"/>
-              </a:rPr>
-              <a:t> has an 8 ft setback”]</a:t>
+              <a:t>"Building fronts public open space”]</a:t>
             </a:r>
           </a:p>
         </p:txBody>
@@ -5707,8 +5684,8 @@
         </p:nvCxnSpPr>
         <p:spPr>
           <a:xfrm rot="16200000" flipH="1">
-            <a:off x="3304165" y="2957280"/>
-            <a:ext cx="440596" cy="677112"/>
+            <a:off x="3391499" y="2869946"/>
+            <a:ext cx="265928" cy="677112"/>
           </a:xfrm>
           <a:prstGeom prst="bentConnector2">
             <a:avLst/>
@@ -5747,7 +5724,7 @@
         <p:spPr>
           <a:xfrm>
             <a:off x="3811355" y="3033567"/>
-            <a:ext cx="2284645" cy="600164"/>
+            <a:ext cx="2284645" cy="430887"/>
           </a:xfrm>
           <a:prstGeom prst="rect">
             <a:avLst/>
@@ -5770,13 +5747,6 @@
             </a:r>
           </a:p>
           <a:p>
-            <a:endParaRPr lang="en-US" sz="1100" dirty="0">
-              <a:latin typeface="Cascadia Mono Light" panose="020B0609020000020004" pitchFamily="49" charset="0"/>
-              <a:ea typeface="Cascadia Mono Light" panose="020B0609020000020004" pitchFamily="49" charset="0"/>
-              <a:cs typeface="Cascadia Mono Light" panose="020B0609020000020004" pitchFamily="49" charset="0"/>
-            </a:endParaRPr>
-          </a:p>
-          <a:p>
             <a:r>
               <a:rPr lang="en-US" sz="1100" dirty="0">
                 <a:latin typeface="Cascadia Mono Light" panose="020B0609020000020004" pitchFamily="49" charset="0"/>
@@ -5924,7 +5894,7 @@
         <p:spPr>
           <a:xfrm>
             <a:off x="4414041" y="3028443"/>
-            <a:ext cx="3304571" cy="430887"/>
+            <a:ext cx="3304571" cy="261610"/>
           </a:xfrm>
           <a:prstGeom prst="rect">
             <a:avLst/>
@@ -5943,33 +5913,7 @@
                 <a:ea typeface="Cascadia Mono Light" panose="020B0609020000020004" pitchFamily="49" charset="0"/>
                 <a:cs typeface="Cascadia Mono Light" panose="020B0609020000020004" pitchFamily="49" charset="0"/>
               </a:rPr>
-              <a:t>["Along a residential street (category C)", </a:t>
-            </a:r>
-          </a:p>
-          <a:p>
-            <a:r>
-              <a:rPr lang="en-US" sz="1100" dirty="0">
-                <a:latin typeface="Cascadia Mono Light" panose="020B0609020000020004" pitchFamily="49" charset="0"/>
-                <a:ea typeface="Cascadia Mono Light" panose="020B0609020000020004" pitchFamily="49" charset="0"/>
-                <a:cs typeface="Cascadia Mono Light" panose="020B0609020000020004" pitchFamily="49" charset="0"/>
-              </a:rPr>
-              <a:t>"75 percent of </a:t>
-            </a:r>
-            <a:r>
-              <a:rPr lang="en-US" sz="1100" dirty="0" err="1">
-                <a:latin typeface="Cascadia Mono Light" panose="020B0609020000020004" pitchFamily="49" charset="0"/>
-                <a:ea typeface="Cascadia Mono Light" panose="020B0609020000020004" pitchFamily="49" charset="0"/>
-                <a:cs typeface="Cascadia Mono Light" panose="020B0609020000020004" pitchFamily="49" charset="0"/>
-              </a:rPr>
-              <a:t>blockface</a:t>
-            </a:r>
-            <a:r>
-              <a:rPr lang="en-US" sz="1100" dirty="0">
-                <a:latin typeface="Cascadia Mono Light" panose="020B0609020000020004" pitchFamily="49" charset="0"/>
-                <a:ea typeface="Cascadia Mono Light" panose="020B0609020000020004" pitchFamily="49" charset="0"/>
-                <a:cs typeface="Cascadia Mono Light" panose="020B0609020000020004" pitchFamily="49" charset="0"/>
-              </a:rPr>
-              <a:t> has a 5 foot setback”]</a:t>
+              <a:t>"Along a residential street (category C)”</a:t>
             </a:r>
           </a:p>
         </p:txBody>
@@ -6060,7 +6004,7 @@
                 <a:ea typeface="Cascadia Mono Light" panose="020B0609020000020004" pitchFamily="49" charset="0"/>
                 <a:cs typeface="Cascadia Mono Light" panose="020B0609020000020004" pitchFamily="49" charset="0"/>
               </a:rPr>
-              <a:t>expression: “10”</a:t>
+              <a:t>expression: “0”</a:t>
             </a:r>
           </a:p>
         </p:txBody>

</xml_diff>